<commit_message>
Finalize semifinal acceptance evidence
</commit_message>
<xml_diff>
--- a/submission/EgoAgentOS_GOAI_Agent_Infra_复赛方案.pptx
+++ b/submission/EgoAgentOS_GOAI_Agent_Infra_复赛方案.pptx
@@ -2,29 +2,29 @@
 <file path=ppt/presentation.xml><?xml version="1.0" encoding="utf-8"?>
 <p:presentation xmlns:p="http://schemas.openxmlformats.org/presentationml/2006/main">
   <p:sldMasterIdLst>
-    <p:sldMasterId xmlns:r="http://schemas.openxmlformats.org/officeDocument/2006/relationships" id="2147483648" r:id="R592516c0eec84571"/>
-    <p:sldMasterId xmlns:r="http://schemas.openxmlformats.org/officeDocument/2006/relationships" id="2147483650" r:id="R11f40df2be434ca7"/>
+    <p:sldMasterId xmlns:r="http://schemas.openxmlformats.org/officeDocument/2006/relationships" id="2147483648" r:id="R43b30b48be444003"/>
+    <p:sldMasterId xmlns:r="http://schemas.openxmlformats.org/officeDocument/2006/relationships" id="2147483650" r:id="R825c415223e94fd9"/>
   </p:sldMasterIdLst>
   <p:notesMasterIdLst>
-    <p:notesMasterId xmlns:r="http://schemas.openxmlformats.org/officeDocument/2006/relationships" r:id="R1bacce2076b0411b"/>
+    <p:notesMasterId xmlns:r="http://schemas.openxmlformats.org/officeDocument/2006/relationships" r:id="Re102eb79ca5441e8"/>
   </p:notesMasterIdLst>
   <p:sldIdLst>
-    <p:sldId xmlns:r="http://schemas.openxmlformats.org/officeDocument/2006/relationships" id="256" r:id="R024acb8c7742468c"/>
-    <p:sldId xmlns:r="http://schemas.openxmlformats.org/officeDocument/2006/relationships" id="257" r:id="Ra28885c529fe44e7"/>
-    <p:sldId xmlns:r="http://schemas.openxmlformats.org/officeDocument/2006/relationships" id="258" r:id="R11b7491667244101"/>
-    <p:sldId xmlns:r="http://schemas.openxmlformats.org/officeDocument/2006/relationships" id="259" r:id="Re1df061e46ea4b4b"/>
-    <p:sldId xmlns:r="http://schemas.openxmlformats.org/officeDocument/2006/relationships" id="260" r:id="R149f52029dc743a0"/>
-    <p:sldId xmlns:r="http://schemas.openxmlformats.org/officeDocument/2006/relationships" id="261" r:id="R67df11d645b940a1"/>
-    <p:sldId xmlns:r="http://schemas.openxmlformats.org/officeDocument/2006/relationships" id="262" r:id="R1dced1255fca44fa"/>
-    <p:sldId xmlns:r="http://schemas.openxmlformats.org/officeDocument/2006/relationships" id="263" r:id="Rfecc9bd275074d7d"/>
-    <p:sldId xmlns:r="http://schemas.openxmlformats.org/officeDocument/2006/relationships" id="264" r:id="Rcb54e30538134ec5"/>
-    <p:sldId xmlns:r="http://schemas.openxmlformats.org/officeDocument/2006/relationships" id="265" r:id="R21226264cc104a62"/>
-    <p:sldId xmlns:r="http://schemas.openxmlformats.org/officeDocument/2006/relationships" id="266" r:id="Rdd0666fded354aa4"/>
-    <p:sldId xmlns:r="http://schemas.openxmlformats.org/officeDocument/2006/relationships" id="267" r:id="Rb9d8279e2ca94e50"/>
-    <p:sldId xmlns:r="http://schemas.openxmlformats.org/officeDocument/2006/relationships" id="268" r:id="R1373c197737d4a48"/>
-    <p:sldId xmlns:r="http://schemas.openxmlformats.org/officeDocument/2006/relationships" id="269" r:id="R201a3fecc132470d"/>
-    <p:sldId xmlns:r="http://schemas.openxmlformats.org/officeDocument/2006/relationships" id="270" r:id="R74ece5a8e2df43c7"/>
-    <p:sldId xmlns:r="http://schemas.openxmlformats.org/officeDocument/2006/relationships" id="271" r:id="R1840a6d303164dbb"/>
+    <p:sldId xmlns:r="http://schemas.openxmlformats.org/officeDocument/2006/relationships" id="256" r:id="Rccf5767554ff4dfd"/>
+    <p:sldId xmlns:r="http://schemas.openxmlformats.org/officeDocument/2006/relationships" id="257" r:id="Rc9733a67d237438b"/>
+    <p:sldId xmlns:r="http://schemas.openxmlformats.org/officeDocument/2006/relationships" id="258" r:id="R4ecbf18ad4ad4ddf"/>
+    <p:sldId xmlns:r="http://schemas.openxmlformats.org/officeDocument/2006/relationships" id="259" r:id="R8e814a2d51da404b"/>
+    <p:sldId xmlns:r="http://schemas.openxmlformats.org/officeDocument/2006/relationships" id="260" r:id="Rc4c4156e026a4641"/>
+    <p:sldId xmlns:r="http://schemas.openxmlformats.org/officeDocument/2006/relationships" id="261" r:id="R10e8afaecc634ec2"/>
+    <p:sldId xmlns:r="http://schemas.openxmlformats.org/officeDocument/2006/relationships" id="262" r:id="Rcd15773153194308"/>
+    <p:sldId xmlns:r="http://schemas.openxmlformats.org/officeDocument/2006/relationships" id="263" r:id="R6202b7dbdfdf441d"/>
+    <p:sldId xmlns:r="http://schemas.openxmlformats.org/officeDocument/2006/relationships" id="264" r:id="R071346e44d7c4ab2"/>
+    <p:sldId xmlns:r="http://schemas.openxmlformats.org/officeDocument/2006/relationships" id="265" r:id="R1beac0bdd5234ca6"/>
+    <p:sldId xmlns:r="http://schemas.openxmlformats.org/officeDocument/2006/relationships" id="266" r:id="R7d7e96832d91441f"/>
+    <p:sldId xmlns:r="http://schemas.openxmlformats.org/officeDocument/2006/relationships" id="267" r:id="Rbc3a6fe56f994fd7"/>
+    <p:sldId xmlns:r="http://schemas.openxmlformats.org/officeDocument/2006/relationships" id="268" r:id="Rc38c3fd411fa4759"/>
+    <p:sldId xmlns:r="http://schemas.openxmlformats.org/officeDocument/2006/relationships" id="269" r:id="Raa71ecbff4a1463f"/>
+    <p:sldId xmlns:r="http://schemas.openxmlformats.org/officeDocument/2006/relationships" id="270" r:id="R261e189470914605"/>
+    <p:sldId xmlns:r="http://schemas.openxmlformats.org/officeDocument/2006/relationships" id="271" r:id="R70bf43aa71334e1f"/>
   </p:sldIdLst>
   <p:sldSz cx="12192000" cy="6858000"/>
   <p:notesSz cx="6858000" cy="9144000"/>
@@ -2114,7 +2114,7 @@
   </p:cSld>
   <p:clrMap bg1="lt1" tx1="dk1" bg2="lt2" tx2="dk2" accent1="accent1" accent2="accent2" accent3="accent3" accent4="accent4" accent5="accent5" accent6="accent6" hlink="hlink" folHlink="folHlink"/>
   <p:sldLayoutIdLst>
-    <p:sldLayoutId xmlns:r="http://schemas.openxmlformats.org/officeDocument/2006/relationships" id="2147483649" r:id="Rb9e9ee07fab14b68"/>
+    <p:sldLayoutId xmlns:r="http://schemas.openxmlformats.org/officeDocument/2006/relationships" id="2147483649" r:id="Re440ee11f557419a"/>
   </p:sldLayoutIdLst>
   <p:hf sldNum="0" hdr="0" ftr="0" dt="0"/>
   <p:txStyles>
@@ -2358,7 +2358,7 @@
   </p:cSld>
   <p:clrMap bg1="lt1" tx1="dk1" bg2="lt2" tx2="dk2" accent1="accent1" accent2="accent2" accent3="accent3" accent4="accent4" accent5="accent5" accent6="accent6" hlink="hlink" folHlink="folHlink"/>
   <p:sldLayoutIdLst>
-    <p:sldLayoutId xmlns:r="http://schemas.openxmlformats.org/officeDocument/2006/relationships" id="2147483651" r:id="Rdd775634da844c4e"/>
+    <p:sldLayoutId xmlns:r="http://schemas.openxmlformats.org/officeDocument/2006/relationships" id="2147483651" r:id="R5d34c1d28d5f4163"/>
   </p:sldLayoutIdLst>
   <p:hf sldNum="0" hdr="0" ftr="0" dt="0"/>
   <p:txStyles>
@@ -3476,7 +3476,7 @@
           <p:nvPr/>
         </p:nvPicPr>
         <p:blipFill>
-          <a:blip xmlns:r="http://schemas.openxmlformats.org/officeDocument/2006/relationships" xmlns:a="http://schemas.openxmlformats.org/drawingml/2006/main" r:embed="R809cf16dc4784383"/>
+          <a:blip xmlns:r="http://schemas.openxmlformats.org/officeDocument/2006/relationships" xmlns:a="http://schemas.openxmlformats.org/drawingml/2006/main" r:embed="R0c1e4fd9713a43ca"/>
           <a:srcRect xmlns:a="http://schemas.openxmlformats.org/drawingml/2006/main" l="2642" t="0" r="2642" b="0"/>
           <a:stretch xmlns:a="http://schemas.openxmlformats.org/drawingml/2006/main">
             <a:fillRect l="0" t="0" r="0" b="0"/>
@@ -3895,7 +3895,7 @@
           <p:nvPr/>
         </p:nvPicPr>
         <p:blipFill>
-          <a:blip xmlns:r="http://schemas.openxmlformats.org/officeDocument/2006/relationships" xmlns:a="http://schemas.openxmlformats.org/drawingml/2006/main" r:embed="R4d17a419aa5044f7"/>
+          <a:blip xmlns:r="http://schemas.openxmlformats.org/officeDocument/2006/relationships" xmlns:a="http://schemas.openxmlformats.org/drawingml/2006/main" r:embed="Rad0a05b33c114937"/>
           <a:srcRect xmlns:a="http://schemas.openxmlformats.org/drawingml/2006/main" l="7355" t="0" r="7355" b="0"/>
           <a:stretch xmlns:a="http://schemas.openxmlformats.org/drawingml/2006/main">
             <a:fillRect l="0" t="0" r="0" b="0"/>
@@ -3920,7 +3920,7 @@
           <p:nvPr/>
         </p:nvPicPr>
         <p:blipFill>
-          <a:blip xmlns:r="http://schemas.openxmlformats.org/officeDocument/2006/relationships" xmlns:a="http://schemas.openxmlformats.org/drawingml/2006/main" r:embed="Rca035c5507334108"/>
+          <a:blip xmlns:r="http://schemas.openxmlformats.org/officeDocument/2006/relationships" xmlns:a="http://schemas.openxmlformats.org/drawingml/2006/main" r:embed="R86969d29c77a44b7"/>
           <a:stretch xmlns:a="http://schemas.openxmlformats.org/drawingml/2006/main"/>
         </p:blipFill>
         <p:spPr>
@@ -4336,7 +4336,7 @@
           <p:nvPr/>
         </p:nvPicPr>
         <p:blipFill>
-          <a:blip xmlns:r="http://schemas.openxmlformats.org/officeDocument/2006/relationships" xmlns:a="http://schemas.openxmlformats.org/drawingml/2006/main" r:embed="R5cf1c480ab4e4e5b"/>
+          <a:blip xmlns:r="http://schemas.openxmlformats.org/officeDocument/2006/relationships" xmlns:a="http://schemas.openxmlformats.org/drawingml/2006/main" r:embed="R10f2c1dfca26439a"/>
           <a:srcRect xmlns:a="http://schemas.openxmlformats.org/drawingml/2006/main" l="7355" t="0" r="7355" b="0"/>
           <a:stretch xmlns:a="http://schemas.openxmlformats.org/drawingml/2006/main">
             <a:fillRect l="0" t="0" r="0" b="0"/>
@@ -4361,7 +4361,7 @@
           <p:nvPr/>
         </p:nvPicPr>
         <p:blipFill>
-          <a:blip xmlns:r="http://schemas.openxmlformats.org/officeDocument/2006/relationships" xmlns:a="http://schemas.openxmlformats.org/drawingml/2006/main" r:embed="Re1b0b3b6d5774b52"/>
+          <a:blip xmlns:r="http://schemas.openxmlformats.org/officeDocument/2006/relationships" xmlns:a="http://schemas.openxmlformats.org/drawingml/2006/main" r:embed="R42ca7623c4e04f81"/>
           <a:stretch xmlns:a="http://schemas.openxmlformats.org/drawingml/2006/main"/>
         </p:blipFill>
         <p:spPr>
@@ -4448,7 +4448,7 @@
                 <a:ea typeface="Noto Sans CJK SC"/>
                 <a:cs typeface="Noto Sans CJK SC"/>
               </a:rPr>
-              <a:t>Evidence · 2026-08-29 本地复测</a:t>
+              <a:t>Evidence · 2026-09-03 最终验收</a:t>
             </a:r>
             <a:endParaRPr sz="1200" b="1">
               <a:solidFill>
@@ -4572,7 +4572,7 @@
                 <a:ea typeface="Noto Sans CJK SC"/>
                 <a:cs typeface="Noto Sans CJK SC"/>
               </a:rPr>
-              <a:t>默认 210 tests 全过；另有 PostgreSQL 16.14 / 27 tests。外部 live 项单列 NOT RUN。</a:t>
+              <a:t>make test：530 PASS / 1 SKIP；full pytest：689 PASS / 1 SKIP；PostgreSQL：38 / 38。</a:t>
             </a:r>
             <a:endParaRPr sz="885" b="1">
               <a:solidFill>
@@ -5329,7 +5329,7 @@
                 <a:ea typeface="Noto Sans CJK SC"/>
                 <a:cs typeface="Noto Sans CJK SC"/>
               </a:rPr>
-              <a:t>210</a:t>
+              <a:t>689</a:t>
             </a:r>
             <a:endParaRPr sz="1500" b="1" i="0">
               <a:solidFill>
@@ -5394,7 +5394,7 @@
                 <a:ea typeface="Noto Sans CJK SC"/>
                 <a:cs typeface="Noto Sans CJK SC"/>
               </a:rPr>
-              <a:t>default suite PASS</a:t>
+              <a:t>full pytest PASS</a:t>
             </a:r>
             <a:endParaRPr sz="790" b="0" i="0">
               <a:solidFill>
@@ -5719,8 +5719,8 @@
                 <a:ea typeface="Noto Sans CJK SC"/>
                 <a:cs typeface="Noto Sans CJK SC"/>
               </a:rPr>
-              <a:t>API 56 · RXP 26 · Skills 6 · Proof 2 · Benchmark 28
-Acceptance 16 · AgentTeams 28 · Experiments 13 · MCP 23 · Web 12</a:t>
+              <a:t>API 89 · RXP 26 · Skills 6 · Proof 3 · Benchmark 29
+Acceptance 16 · AgentTeams 264 · Experiments 16 · MCP 53 · Web 28</a:t>
             </a:r>
             <a:endParaRPr sz="720" b="0" i="0">
               <a:solidFill>
@@ -5785,7 +5785,7 @@
                 <a:ea typeface="Noto Sans CJK SC"/>
                 <a:cs typeface="Noto Sans CJK SC"/>
               </a:rPr>
-              <a:t>12</a:t>
+              <a:t>28</a:t>
             </a:r>
             <a:endParaRPr sz="1500" b="1" i="0">
               <a:solidFill>
@@ -6370,7 +6370,7 @@
                 <a:ea typeface="Noto Sans CJK SC"/>
                 <a:cs typeface="Noto Sans CJK SC"/>
               </a:rPr>
-              <a:t>28</a:t>
+              <a:t>264</a:t>
             </a:r>
             <a:endParaRPr sz="1500" b="1" i="0">
               <a:solidFill>
@@ -6500,7 +6500,7 @@
                 <a:ea typeface="Noto Sans CJK SC"/>
                 <a:cs typeface="Noto Sans CJK SC"/>
               </a:rPr>
-              <a:t>27</a:t>
+              <a:t>38</a:t>
             </a:r>
             <a:endParaRPr sz="1500" b="1" i="0">
               <a:solidFill>
@@ -6630,7 +6630,7 @@
                 <a:ea typeface="Noto Sans CJK SC"/>
                 <a:cs typeface="Noto Sans CJK SC"/>
               </a:rPr>
-              <a:t>NOT RUN</a:t>
+              <a:t>PENDING</a:t>
             </a:r>
             <a:endParaRPr sz="1500" b="1" i="0">
               <a:solidFill>
@@ -6695,7 +6695,7 @@
                 <a:ea typeface="Noto Sans CJK SC"/>
                 <a:cs typeface="Noto Sans CJK SC"/>
               </a:rPr>
-              <a:t>external live</a:t>
+              <a:t>workflow</a:t>
             </a:r>
             <a:endParaRPr sz="790" b="0" i="0">
               <a:solidFill>
@@ -6760,7 +6760,7 @@
                 <a:ea typeface="Noto Sans CJK SC"/>
                 <a:cs typeface="Noto Sans CJK SC"/>
               </a:rPr>
-              <a:t>bridge/trace 与本地 PG 实库通过；official AgentTeams、GPU、PolarDB 不在此结果中。</a:t>
+              <a:t>official infra / Matrix 已 LIVE_LOCAL；科研 workflow、GPU、Nexa / PITR 未运行。</a:t>
             </a:r>
             <a:endParaRPr sz="705" b="0" i="0">
               <a:solidFill>
@@ -7280,7 +7280,7 @@
                 <a:ea typeface="Noto Sans CJK SC"/>
                 <a:cs typeface="Noto Sans CJK SC"/>
               </a:rPr>
-              <a:t>证据命令：make test · pytest tests/postgres · ego-semifinal-bundle verify · make package</a:t>
+              <a:t>证据命令：make test · pytest tests/postgres · freeze_live_local_proof.py · make package</a:t>
             </a:r>
             <a:endParaRPr sz="700" b="1" i="0">
               <a:solidFill>
@@ -9288,7 +9288,7 @@
                 <a:ea typeface="Noto Sans CJK SC"/>
                 <a:cs typeface="Noto Sans CJK SC"/>
               </a:rPr>
-              <a:t>checkpoint</a:t>
+              <a:t>检查点</a:t>
             </a:r>
             <a:endParaRPr sz="1500" b="1" i="0">
               <a:solidFill>
@@ -9678,7 +9678,7 @@
                 <a:ea typeface="Noto Sans CJK SC"/>
                 <a:cs typeface="Noto Sans CJK SC"/>
               </a:rPr>
-              <a:t>SQLite local 与 PostgreSQL profile 都要求重启后读取 authoritative state。</a:t>
+              <a:t>SQLite dev 与 PostgreSQL profile 都要求重启后读取 authoritative state。</a:t>
             </a:r>
             <a:endParaRPr sz="705" b="0" i="0">
               <a:solidFill>
@@ -10499,7 +10499,7 @@
                 <a:ea typeface="Noto Sans CJK SC"/>
                 <a:cs typeface="Noto Sans CJK SC"/>
               </a:rPr>
-              <a:t>SQLite 仅作 dev fallback；PostgreSQL 是生产路径，承载并发、权限、通知与不可变账本。PolarDB 仍需云端实证。</a:t>
+              <a:t>SQLite 仅作 dev fallback；PostgreSQL 生产语义已验证；TDSQL Nexa / Agent Memory 云端仍待实证。</a:t>
             </a:r>
             <a:endParaRPr sz="975">
               <a:solidFill>
@@ -12909,7 +12909,7 @@
                 <a:ea typeface="Noto Sans CJK SC"/>
                 <a:cs typeface="Noto Sans CJK SC"/>
               </a:rPr>
-              <a:t>PostgreSQL 16.14 · 27 integration tests</a:t>
+              <a:t>PostgreSQL 16 · 38 integration tests</a:t>
             </a:r>
             <a:endParaRPr sz="675" b="0" i="0">
               <a:solidFill>
@@ -13185,7 +13185,7 @@
                 <a:ea typeface="Noto Sans CJK SC"/>
                 <a:cs typeface="Noto Sans CJK SC"/>
               </a:rPr>
-              <a:t>PolarDB · PITR · read/write split · cloud IAM</a:t>
+              <a:t>TDSQL Nexa · Agent Memory · PITR · cloud IAM</a:t>
             </a:r>
             <a:endParaRPr sz="675" b="0" i="0">
               <a:solidFill>
@@ -13599,7 +13599,7 @@
                 <a:ea typeface="Noto Sans CJK SC"/>
                 <a:cs typeface="Noto Sans CJK SC"/>
               </a:rPr>
-              <a:t>preflight PASS + restore / failover drill</a:t>
+              <a:t>Nexa preflight + restore / failover drill</a:t>
             </a:r>
             <a:endParaRPr sz="675" b="0" i="0">
               <a:solidFill>
@@ -14485,7 +14485,7 @@
                 <a:ea typeface="Noto Sans CJK SC"/>
                 <a:cs typeface="Noto Sans CJK SC"/>
               </a:rPr>
-              <a:t>PostgreSQL 16.14 + AgentTeams bridge contracts</a:t>
+              <a:t>PostgreSQL 16 + AgentTeams LIVE_LOCAL</a:t>
             </a:r>
             <a:endParaRPr sz="805" b="1" i="0">
               <a:solidFill>
@@ -14550,7 +14550,7 @@
                 <a:ea typeface="Noto Sans CJK SC"/>
                 <a:cs typeface="Noto Sans CJK SC"/>
               </a:rPr>
-              <a:t>PG 27 + bridge 28；账本篡改、receipt 重用、崩溃恢复与来源冒充均有负测。</a:t>
+              <a:t>PG 38 + bridge 264；Controller / Manager / 4 Workers / Matrix smoke 已联通。</a:t>
             </a:r>
             <a:endParaRPr sz="655" b="0" i="0">
               <a:solidFill>
@@ -14656,7 +14656,7 @@
                 <a:ea typeface="Noto Sans CJK SC"/>
                 <a:cs typeface="Noto Sans CJK SC"/>
               </a:rPr>
-              <a:t>仍为 SKIP</a:t>
+              <a:t>仍未运行</a:t>
             </a:r>
             <a:endParaRPr sz="615" b="1">
               <a:solidFill>
@@ -14721,7 +14721,7 @@
                 <a:ea typeface="Noto Sans CJK SC"/>
                 <a:cs typeface="Noto Sans CJK SC"/>
               </a:rPr>
-              <a:t>official AgentTeams · single GPU · PolarDB / PITR</a:t>
+              <a:t>科研 workflow · GPU · Nexa / PITR</a:t>
             </a:r>
             <a:endParaRPr sz="805" b="1" i="0">
               <a:solidFill>
@@ -14786,7 +14786,7 @@
                 <a:ea typeface="Noto Sans CJK SC"/>
                 <a:cs typeface="Noto Sans CJK SC"/>
               </a:rPr>
-              <a:t>没有可认证 origin、endpoint 与 same-run trace，就不把 contract 写成 live 成功。</a:t>
+              <a:t>Project 的 8 nodes 均 PENDING；没有 GPU receipt 与 same-run trace 就不写成闭环成功。</a:t>
             </a:r>
             <a:endParaRPr sz="655" b="0" i="0">
               <a:solidFill>
@@ -16681,7 +16681,7 @@
                 <a:ea typeface="Noto Sans CJK SC"/>
                 <a:cs typeface="Noto Sans CJK SC"/>
               </a:rPr>
-              <a:t>GitHub Pages 仅托管 static judge replay；API / AgentTeams / PostgreSQL capability 必须由本地或部署 profile 证明</a:t>
+              <a:t>Pages 提供 LIVE_BROWSER 专家规划 + synthetic replay；AgentTeams / PostgreSQL 由 LIVE_LOCAL 证据证明</a:t>
             </a:r>
             <a:endParaRPr sz="645" b="1" i="0">
               <a:solidFill>
@@ -17509,7 +17509,7 @@
                 <a:ea typeface="Noto Sans CJK SC"/>
                 <a:cs typeface="Noto Sans CJK SC"/>
               </a:rPr>
-              <a:t>AgentTeams → 人工审批 → bounded single-GPU contract。</a:t>
+              <a:t>展示 AgentTeams LIVE_LOCAL、冻结 workflow 与 R2 授权合同。</a:t>
             </a:r>
             <a:endParaRPr sz="655" b="0" i="0">
               <a:solidFill>
@@ -17716,7 +17716,7 @@
                 <a:ea typeface="Noto Sans CJK SC"/>
                 <a:cs typeface="Noto Sans CJK SC"/>
               </a:rPr>
-              <a:t>raw metrics → deterministic eval → reviewer → Decision。</a:t>
+              <a:t>步进 synthetic run：raw metrics → eval → reviewer → Decision。</a:t>
             </a:r>
             <a:endParaRPr sz="655" b="0" i="0">
               <a:solidFill>
@@ -17923,7 +17923,7 @@
                 <a:ea typeface="Noto Sans CJK SC"/>
                 <a:cs typeface="Noto Sans CJK SC"/>
               </a:rPr>
-              <a:t>PG roles / recovery、benchmark 与 NOT RUN boundary。</a:t>
+              <a:t>PG 38/38、Matrix proof、recovery 与 NOT RUN boundary。</a:t>
             </a:r>
             <a:endParaRPr sz="655" b="0" i="0">
               <a:solidFill>
@@ -18533,7 +18533,7 @@
                 <a:ea typeface="Noto Sans CJK SC"/>
                 <a:cs typeface="Noto Sans CJK SC"/>
               </a:rPr>
-              <a:t>make test · PostgreSQL 27 · acceptance bundle verify</a:t>
+              <a:t>make test · PostgreSQL 38 · LIVE_LOCAL proof</a:t>
             </a:r>
             <a:endParaRPr sz="675" b="0" i="0">
               <a:solidFill>
@@ -19196,7 +19196,7 @@
                 <a:ea typeface="Noto Sans CJK SC"/>
                 <a:cs typeface="Noto Sans CJK SC"/>
               </a:rPr>
-              <a:t>AgentTeams + bounded GPU chain</a:t>
+              <a:t>Official AgentTeams · 4 Worker resources</a:t>
             </a:r>
             <a:endParaRPr sz="1065">
               <a:solidFill>
@@ -19257,7 +19257,7 @@
                 <a:ea typeface="Noto Sans CJK SC"/>
                 <a:cs typeface="Noto Sans CJK SC"/>
               </a:rPr>
-              <a:t>bridge · recovery｜official live NOT RUN</a:t>
+              <a:t>Controller / Manager / Team / Matrix · LIVE_LOCAL</a:t>
             </a:r>
             <a:endParaRPr sz="990" b="1" i="1">
               <a:solidFill>
@@ -20467,7 +20467,7 @@
                 <a:ea typeface="Noto Sans CJK SC"/>
                 <a:cs typeface="Noto Sans CJK SC"/>
               </a:rPr>
-              <a:t>official AgentTeams · GPU · PolarDB/PITR 不冒认</a:t>
+              <a:t>workflow / GPU / Nexa / PITR 不冒认</a:t>
             </a:r>
             <a:endParaRPr sz="990" b="1" i="1">
               <a:solidFill>
@@ -21671,7 +21671,7 @@
       </p:sp>
       <p:cxnSp>
         <p:nvCxnSpPr>
-          <p:cNvPr id="225" name="直接箭头连接符 56"/>
+          <p:cNvPr id="246" name="直接箭头连接符 56"/>
           <p:cNvCxnSpPr>
             <a:stCxn xmlns:a="http://schemas.openxmlformats.org/drawingml/2006/main" id="12" idx="3"/>
             <a:endCxn xmlns:a="http://schemas.openxmlformats.org/drawingml/2006/main" id="17" idx="1"/>
@@ -21697,7 +21697,7 @@
       </p:cxnSp>
       <p:cxnSp>
         <p:nvCxnSpPr>
-          <p:cNvPr id="226" name="直接箭头连接符 57"/>
+          <p:cNvPr id="247" name="直接箭头连接符 57"/>
           <p:cNvCxnSpPr>
             <a:stCxn xmlns:a="http://schemas.openxmlformats.org/drawingml/2006/main" id="13" idx="3"/>
             <a:endCxn xmlns:a="http://schemas.openxmlformats.org/drawingml/2006/main" id="17" idx="1"/>
@@ -21723,7 +21723,7 @@
       </p:cxnSp>
       <p:cxnSp>
         <p:nvCxnSpPr>
-          <p:cNvPr id="227" name="直接箭头连接符 58"/>
+          <p:cNvPr id="248" name="直接箭头连接符 58"/>
           <p:cNvCxnSpPr>
             <a:stCxn xmlns:a="http://schemas.openxmlformats.org/drawingml/2006/main" id="14" idx="3"/>
             <a:endCxn xmlns:a="http://schemas.openxmlformats.org/drawingml/2006/main" id="17" idx="1"/>
@@ -21749,7 +21749,7 @@
       </p:cxnSp>
       <p:cxnSp>
         <p:nvCxnSpPr>
-          <p:cNvPr id="228" name="直接箭头连接符 59"/>
+          <p:cNvPr id="249" name="直接箭头连接符 59"/>
           <p:cNvCxnSpPr>
             <a:stCxn xmlns:a="http://schemas.openxmlformats.org/drawingml/2006/main" id="15" idx="3"/>
             <a:endCxn xmlns:a="http://schemas.openxmlformats.org/drawingml/2006/main" id="17" idx="1"/>
@@ -21775,7 +21775,7 @@
       </p:cxnSp>
       <p:cxnSp>
         <p:nvCxnSpPr>
-          <p:cNvPr id="229" name="直接箭头连接符 60"/>
+          <p:cNvPr id="250" name="直接箭头连接符 60"/>
           <p:cNvCxnSpPr>
             <a:stCxn xmlns:a="http://schemas.openxmlformats.org/drawingml/2006/main" id="16" idx="3"/>
             <a:endCxn xmlns:a="http://schemas.openxmlformats.org/drawingml/2006/main" id="17" idx="1"/>
@@ -21801,7 +21801,7 @@
       </p:cxnSp>
       <p:cxnSp>
         <p:nvCxnSpPr>
-          <p:cNvPr id="230" name="直接箭头连接符 61"/>
+          <p:cNvPr id="251" name="直接箭头连接符 61"/>
           <p:cNvCxnSpPr>
             <a:stCxn xmlns:a="http://schemas.openxmlformats.org/drawingml/2006/main" id="17" idx="3"/>
             <a:endCxn xmlns:a="http://schemas.openxmlformats.org/drawingml/2006/main" id="18" idx="1"/>
@@ -26232,7 +26232,7 @@
       </p:sp>
       <p:cxnSp>
         <p:nvCxnSpPr>
-          <p:cNvPr id="639" name="直接箭头连接符 158"/>
+          <p:cNvPr id="699" name="直接箭头连接符 158"/>
           <p:cNvCxnSpPr>
             <a:stCxn xmlns:a="http://schemas.openxmlformats.org/drawingml/2006/main" id="41" idx="3"/>
             <a:endCxn xmlns:a="http://schemas.openxmlformats.org/drawingml/2006/main" id="47" idx="1"/>
@@ -26258,7 +26258,7 @@
       </p:cxnSp>
       <p:cxnSp>
         <p:nvCxnSpPr>
-          <p:cNvPr id="640" name="直接箭头连接符 159"/>
+          <p:cNvPr id="700" name="直接箭头连接符 159"/>
           <p:cNvCxnSpPr>
             <a:stCxn xmlns:a="http://schemas.openxmlformats.org/drawingml/2006/main" id="42" idx="3"/>
             <a:endCxn xmlns:a="http://schemas.openxmlformats.org/drawingml/2006/main" id="47" idx="1"/>
@@ -26284,7 +26284,7 @@
       </p:cxnSp>
       <p:cxnSp>
         <p:nvCxnSpPr>
-          <p:cNvPr id="641" name="直接箭头连接符 160"/>
+          <p:cNvPr id="701" name="直接箭头连接符 160"/>
           <p:cNvCxnSpPr>
             <a:stCxn xmlns:a="http://schemas.openxmlformats.org/drawingml/2006/main" id="43" idx="3"/>
             <a:endCxn xmlns:a="http://schemas.openxmlformats.org/drawingml/2006/main" id="47" idx="1"/>
@@ -26310,7 +26310,7 @@
       </p:cxnSp>
       <p:cxnSp>
         <p:nvCxnSpPr>
-          <p:cNvPr id="642" name="直接箭头连接符 161"/>
+          <p:cNvPr id="702" name="直接箭头连接符 161"/>
           <p:cNvCxnSpPr>
             <a:stCxn xmlns:a="http://schemas.openxmlformats.org/drawingml/2006/main" id="44" idx="3"/>
             <a:endCxn xmlns:a="http://schemas.openxmlformats.org/drawingml/2006/main" id="47" idx="1"/>
@@ -26336,7 +26336,7 @@
       </p:cxnSp>
       <p:cxnSp>
         <p:nvCxnSpPr>
-          <p:cNvPr id="643" name="直接箭头连接符 162"/>
+          <p:cNvPr id="703" name="直接箭头连接符 162"/>
           <p:cNvCxnSpPr>
             <a:stCxn xmlns:a="http://schemas.openxmlformats.org/drawingml/2006/main" id="45" idx="3"/>
             <a:endCxn xmlns:a="http://schemas.openxmlformats.org/drawingml/2006/main" id="47" idx="1"/>
@@ -26898,7 +26898,7 @@
                 <a:ea typeface="Noto Sans CJK SC"/>
                 <a:cs typeface="Noto Sans CJK SC"/>
               </a:rPr>
-              <a:t>contract + local PG 可重放；official AgentTeams / GPU / PolarDB / PITR = NOT RUN</a:t>
+              <a:t>AgentTeams infra / Matrix = LIVE_LOCAL；workflow / GPU / Nexa / PITR = NOT RUN</a:t>
             </a:r>
             <a:endParaRPr sz="775" b="0" i="0">
               <a:solidFill>
@@ -30205,7 +30205,7 @@
       </p:sp>
       <p:cxnSp>
         <p:nvCxnSpPr>
-          <p:cNvPr id="639" name="直接箭头连接符 158"/>
+          <p:cNvPr id="699" name="直接箭头连接符 158"/>
           <p:cNvCxnSpPr>
             <a:stCxn xmlns:a="http://schemas.openxmlformats.org/drawingml/2006/main" id="41" idx="3"/>
             <a:endCxn xmlns:a="http://schemas.openxmlformats.org/drawingml/2006/main" id="47" idx="1"/>
@@ -30231,7 +30231,7 @@
       </p:cxnSp>
       <p:cxnSp>
         <p:nvCxnSpPr>
-          <p:cNvPr id="640" name="直接箭头连接符 159"/>
+          <p:cNvPr id="700" name="直接箭头连接符 159"/>
           <p:cNvCxnSpPr>
             <a:stCxn xmlns:a="http://schemas.openxmlformats.org/drawingml/2006/main" id="42" idx="3"/>
             <a:endCxn xmlns:a="http://schemas.openxmlformats.org/drawingml/2006/main" id="47" idx="1"/>
@@ -30257,7 +30257,7 @@
       </p:cxnSp>
       <p:cxnSp>
         <p:nvCxnSpPr>
-          <p:cNvPr id="641" name="直接箭头连接符 160"/>
+          <p:cNvPr id="701" name="直接箭头连接符 160"/>
           <p:cNvCxnSpPr>
             <a:stCxn xmlns:a="http://schemas.openxmlformats.org/drawingml/2006/main" id="43" idx="3"/>
             <a:endCxn xmlns:a="http://schemas.openxmlformats.org/drawingml/2006/main" id="47" idx="1"/>
@@ -30283,7 +30283,7 @@
       </p:cxnSp>
       <p:cxnSp>
         <p:nvCxnSpPr>
-          <p:cNvPr id="642" name="直接箭头连接符 161"/>
+          <p:cNvPr id="702" name="直接箭头连接符 161"/>
           <p:cNvCxnSpPr>
             <a:stCxn xmlns:a="http://schemas.openxmlformats.org/drawingml/2006/main" id="44" idx="3"/>
             <a:endCxn xmlns:a="http://schemas.openxmlformats.org/drawingml/2006/main" id="47" idx="1"/>
@@ -30309,7 +30309,7 @@
       </p:cxnSp>
       <p:cxnSp>
         <p:nvCxnSpPr>
-          <p:cNvPr id="643" name="直接箭头连接符 162"/>
+          <p:cNvPr id="703" name="直接箭头连接符 162"/>
           <p:cNvCxnSpPr>
             <a:stCxn xmlns:a="http://schemas.openxmlformats.org/drawingml/2006/main" id="45" idx="3"/>
             <a:endCxn xmlns:a="http://schemas.openxmlformats.org/drawingml/2006/main" id="47" idx="1"/>
@@ -30958,7 +30958,7 @@
                 <a:ea typeface="Noto Sans CJK SC"/>
                 <a:cs typeface="Noto Sans CJK SC"/>
               </a:rPr>
-              <a:t>AgentTeams · Dynamic collaboration</a:t>
+              <a:t>AgentTeams · LIVE_LOCAL infrastructure</a:t>
             </a:r>
             <a:endParaRPr sz="1200" b="1">
               <a:solidFill>
@@ -31016,7 +31016,7 @@
                 <a:ea typeface="Noto Sans CJK SC"/>
                 <a:cs typeface="Noto Sans CJK SC"/>
               </a:rPr>
-              <a:t>冲突、超时与失败会改变路由</a:t>
+              <a:t>基础设施已联通；科研工作流仍冻结</a:t>
             </a:r>
             <a:endParaRPr sz="2900" b="1">
               <a:solidFill>
@@ -35370,7 +35370,7 @@
                 <a:ea typeface="Noto Sans CJK SC"/>
                 <a:cs typeface="Noto Sans CJK SC"/>
               </a:rPr>
-              <a:t>bridge + PostgreSQL contracts 已验证；official service / Matrix / GPU 未实跑，target 必须 SKIP</a:t>
+              <a:t>Controller / Manager / 4 Workers / Matrix = LIVE_LOCAL；8 nodes PENDING；GPU NOT_ATTACHED</a:t>
             </a:r>
             <a:endParaRPr sz="700" b="1" i="0">
               <a:solidFill>

</xml_diff>